<commit_message>
Video: make slide template + guide topic-centric (reusable across books)
Title/thumbnail placeholders now say Topic/Subject (not a specific book); guide notes topic-based
naming and that one video ID can be embedded in multiple books' Videos sheets.

Co-Authored-By: Claude Opus 4.8 (1M context) <noreply@anthropic.com>
</commit_message>
<xml_diff>
--- a/templates/3R-Academy-Video-Template.pptx
+++ b/templates/3R-Academy-Video-Template.pptx
@@ -3368,7 +3368,7 @@
                 </a:solidFill>
                 <a:latin typeface="Arial"/>
               </a:rPr>
-              <a:t>Chapter title</a:t>
+              <a:t>Topic title</a:t>
             </a:r>
           </a:p>
           <a:p>
@@ -3415,7 +3415,7 @@
                 </a:solidFill>
                 <a:latin typeface="Arial"/>
               </a:rPr>
-              <a:t>Health Assistant — Loksewa · Chapter 5</a:t>
+              <a:t>Subject area  (e.g. Public Health)</a:t>
             </a:r>
           </a:p>
         </p:txBody>
@@ -5714,7 +5714,7 @@
                 </a:solidFill>
                 <a:latin typeface="Arial"/>
               </a:rPr>
-              <a:t>CHAPTER TOPIC</a:t>
+              <a:t>TOPIC</a:t>
             </a:r>
           </a:p>
           <a:p>
@@ -5761,7 +5761,7 @@
                 </a:solidFill>
                 <a:latin typeface="Arial"/>
               </a:rPr>
-              <a:t>Health Assistant — Loksewa  ·  by Dr. Mukesh Adhikari</a:t>
+              <a:t>3R Academy  ·  by Dr. Mukesh Adhikari</a:t>
             </a:r>
           </a:p>
         </p:txBody>

</xml_diff>